<commit_message>
Add category-format ingestion support, samples, tests, and docs updates
</commit_message>
<xml_diff>
--- a/docs/presentation/SODP_Phase1_Presentation_Draft.pptx
+++ b/docs/presentation/SODP_Phase1_Presentation_Draft.pptx
@@ -10,20 +10,20 @@
     <p:sldId id="258" r:id="rId4"/>
     <p:sldId id="259" r:id="rId5"/>
     <p:sldId id="260" r:id="rId6"/>
-    <p:sldId id="261" r:id="rId7"/>
-    <p:sldId id="262" r:id="rId8"/>
-    <p:sldId id="263" r:id="rId9"/>
-    <p:sldId id="264" r:id="rId10"/>
-    <p:sldId id="265" r:id="rId11"/>
-    <p:sldId id="266" r:id="rId12"/>
-    <p:sldId id="267" r:id="rId13"/>
-    <p:sldId id="268" r:id="rId14"/>
-    <p:sldId id="269" r:id="rId15"/>
-    <p:sldId id="270" r:id="rId16"/>
-    <p:sldId id="271" r:id="rId17"/>
-    <p:sldId id="272" r:id="rId18"/>
-    <p:sldId id="273" r:id="rId19"/>
-    <p:sldId id="274" r:id="rId20"/>
+    <p:sldId id="262" r:id="rId7"/>
+    <p:sldId id="263" r:id="rId8"/>
+    <p:sldId id="264" r:id="rId9"/>
+    <p:sldId id="265" r:id="rId10"/>
+    <p:sldId id="266" r:id="rId11"/>
+    <p:sldId id="267" r:id="rId12"/>
+    <p:sldId id="268" r:id="rId13"/>
+    <p:sldId id="269" r:id="rId14"/>
+    <p:sldId id="270" r:id="rId15"/>
+    <p:sldId id="271" r:id="rId16"/>
+    <p:sldId id="272" r:id="rId17"/>
+    <p:sldId id="273" r:id="rId18"/>
+    <p:sldId id="274" r:id="rId19"/>
+    <p:sldId id="280" r:id="rId20"/>
     <p:sldId id="275" r:id="rId21"/>
     <p:sldId id="276" r:id="rId22"/>
     <p:sldId id="277" r:id="rId23"/>
@@ -325,7 +325,7 @@
           <a:p>
             <a:fld id="{5BCAD085-E8A6-8845-BD4E-CB4CCA059FC4}" type="datetimeFigureOut">
               <a:rPr lang="en-US" smtClean="0"/>
-              <a:t>7/15/2026</a:t>
+              <a:t>7/20/2026</a:t>
             </a:fld>
             <a:endParaRPr lang="en-US"/>
           </a:p>
@@ -493,7 +493,7 @@
           <a:p>
             <a:fld id="{5BCAD085-E8A6-8845-BD4E-CB4CCA059FC4}" type="datetimeFigureOut">
               <a:rPr lang="en-US" smtClean="0"/>
-              <a:t>7/15/2026</a:t>
+              <a:t>7/20/2026</a:t>
             </a:fld>
             <a:endParaRPr lang="en-US"/>
           </a:p>
@@ -671,7 +671,7 @@
           <a:p>
             <a:fld id="{5BCAD085-E8A6-8845-BD4E-CB4CCA059FC4}" type="datetimeFigureOut">
               <a:rPr lang="en-US" smtClean="0"/>
-              <a:t>7/15/2026</a:t>
+              <a:t>7/20/2026</a:t>
             </a:fld>
             <a:endParaRPr lang="en-US"/>
           </a:p>
@@ -839,7 +839,7 @@
           <a:p>
             <a:fld id="{5BCAD085-E8A6-8845-BD4E-CB4CCA059FC4}" type="datetimeFigureOut">
               <a:rPr lang="en-US" smtClean="0"/>
-              <a:t>7/15/2026</a:t>
+              <a:t>7/20/2026</a:t>
             </a:fld>
             <a:endParaRPr lang="en-US"/>
           </a:p>
@@ -1084,7 +1084,7 @@
           <a:p>
             <a:fld id="{5BCAD085-E8A6-8845-BD4E-CB4CCA059FC4}" type="datetimeFigureOut">
               <a:rPr lang="en-US" smtClean="0"/>
-              <a:t>7/15/2026</a:t>
+              <a:t>7/20/2026</a:t>
             </a:fld>
             <a:endParaRPr lang="en-US"/>
           </a:p>
@@ -1369,7 +1369,7 @@
           <a:p>
             <a:fld id="{5BCAD085-E8A6-8845-BD4E-CB4CCA059FC4}" type="datetimeFigureOut">
               <a:rPr lang="en-US" smtClean="0"/>
-              <a:t>7/15/2026</a:t>
+              <a:t>7/20/2026</a:t>
             </a:fld>
             <a:endParaRPr lang="en-US"/>
           </a:p>
@@ -1788,7 +1788,7 @@
           <a:p>
             <a:fld id="{5BCAD085-E8A6-8845-BD4E-CB4CCA059FC4}" type="datetimeFigureOut">
               <a:rPr lang="en-US" smtClean="0"/>
-              <a:t>7/15/2026</a:t>
+              <a:t>7/20/2026</a:t>
             </a:fld>
             <a:endParaRPr lang="en-US"/>
           </a:p>
@@ -1905,7 +1905,7 @@
           <a:p>
             <a:fld id="{5BCAD085-E8A6-8845-BD4E-CB4CCA059FC4}" type="datetimeFigureOut">
               <a:rPr lang="en-US" smtClean="0"/>
-              <a:t>7/15/2026</a:t>
+              <a:t>7/20/2026</a:t>
             </a:fld>
             <a:endParaRPr lang="en-US"/>
           </a:p>
@@ -2000,7 +2000,7 @@
           <a:p>
             <a:fld id="{5BCAD085-E8A6-8845-BD4E-CB4CCA059FC4}" type="datetimeFigureOut">
               <a:rPr lang="en-US" smtClean="0"/>
-              <a:t>7/15/2026</a:t>
+              <a:t>7/20/2026</a:t>
             </a:fld>
             <a:endParaRPr lang="en-US"/>
           </a:p>
@@ -2275,7 +2275,7 @@
           <a:p>
             <a:fld id="{5BCAD085-E8A6-8845-BD4E-CB4CCA059FC4}" type="datetimeFigureOut">
               <a:rPr lang="en-US" smtClean="0"/>
-              <a:t>7/15/2026</a:t>
+              <a:t>7/20/2026</a:t>
             </a:fld>
             <a:endParaRPr lang="en-US"/>
           </a:p>
@@ -2527,7 +2527,7 @@
           <a:p>
             <a:fld id="{5BCAD085-E8A6-8845-BD4E-CB4CCA059FC4}" type="datetimeFigureOut">
               <a:rPr lang="en-US" smtClean="0"/>
-              <a:t>7/15/2026</a:t>
+              <a:t>7/20/2026</a:t>
             </a:fld>
             <a:endParaRPr lang="en-US"/>
           </a:p>
@@ -2738,7 +2738,7 @@
           <a:p>
             <a:fld id="{5BCAD085-E8A6-8845-BD4E-CB4CCA059FC4}" type="datetimeFigureOut">
               <a:rPr lang="en-US" smtClean="0"/>
-              <a:t>7/15/2026</a:t>
+              <a:t>7/20/2026</a:t>
             </a:fld>
             <a:endParaRPr lang="en-US"/>
           </a:p>
@@ -3319,7 +3319,7 @@
           <a:lstStyle/>
           <a:p>
             <a:r>
-              <a:t>Repository Structure (High Level)</a:t>
+              <a:t>Runtime Services and Ports</a:t>
             </a:r>
           </a:p>
         </p:txBody>
@@ -3343,71 +3343,63 @@
               <a:defRPr sz="2000"/>
             </a:pPr>
             <a:r>
-              <a:t>config: runtime YAML configuration</a:t>
-            </a:r>
-          </a:p>
-          <a:p>
-            <a:pPr>
-              <a:defRPr sz="2000"/>
-            </a:pPr>
-            <a:r>
-              <a:t>metadata: source/routing/validation/stream definitions</a:t>
-            </a:r>
-          </a:p>
-          <a:p>
-            <a:pPr>
-              <a:defRPr sz="2000"/>
-            </a:pPr>
-            <a:r>
-              <a:t>schemas: per-source JSON schemas</a:t>
-            </a:r>
-          </a:p>
-          <a:p>
-            <a:pPr>
-              <a:defRPr sz="2000"/>
-            </a:pPr>
-            <a:r>
-              <a:t>sample-data: test payloads</a:t>
-            </a:r>
-          </a:p>
-          <a:p>
-            <a:pPr>
-              <a:defRPr sz="2000"/>
-            </a:pPr>
-            <a:r>
-              <a:t>common: shared components (models, validation, storage, aws, repository)</a:t>
-            </a:r>
-          </a:p>
-          <a:p>
-            <a:pPr>
-              <a:defRPr sz="2000"/>
-            </a:pPr>
-            <a:r>
-              <a:t>ingestion-service: API service implementation</a:t>
-            </a:r>
-          </a:p>
-          <a:p>
-            <a:pPr>
-              <a:defRPr sz="2000"/>
-            </a:pPr>
-            <a:r>
-              <a:t>infrastructure/postgres/init.sql: DB bootstrap</a:t>
-            </a:r>
-          </a:p>
-          <a:p>
-            <a:pPr>
-              <a:defRPr sz="2000"/>
-            </a:pPr>
-            <a:r>
-              <a:t>infrastructure/localstack/init-aws.sh: S3/Kinesis bootstrap</a:t>
-            </a:r>
-          </a:p>
-          <a:p>
-            <a:pPr>
-              <a:defRPr sz="2000"/>
-            </a:pPr>
-            <a:r>
-              <a:t>tests: offline-capable pytest suite</a:t>
+              <a:t>Ingestion API: http://localhost:8000/api/v1</a:t>
+            </a:r>
+          </a:p>
+          <a:p>
+            <a:pPr>
+              <a:defRPr sz="2000"/>
+            </a:pPr>
+            <a:r>
+              <a:t>Swagger UI: http://localhost:8000/docs</a:t>
+            </a:r>
+          </a:p>
+          <a:p>
+            <a:pPr>
+              <a:defRPr sz="2000"/>
+            </a:pPr>
+            <a:r>
+              <a:t>Health: http://localhost:8000/api/v1/health</a:t>
+            </a:r>
+          </a:p>
+          <a:p>
+            <a:pPr>
+              <a:defRPr sz="2000"/>
+            </a:pPr>
+            <a:r>
+              <a:t>LocalStack: http://localhost:4566</a:t>
+            </a:r>
+          </a:p>
+          <a:p>
+            <a:pPr>
+              <a:defRPr sz="2000"/>
+            </a:pPr>
+            <a:r>
+              <a:t>PostgreSQL: localhost:5432</a:t>
+            </a:r>
+          </a:p>
+          <a:p>
+            <a:pPr>
+              <a:defRPr sz="2000"/>
+            </a:pPr>
+            <a:r>
+              <a:t>pgAdmin: http://localhost:5050</a:t>
+            </a:r>
+          </a:p>
+          <a:p>
+            <a:pPr>
+              <a:defRPr sz="2000"/>
+            </a:pPr>
+            <a:r>
+              <a:t>Prometheus: http://localhost:9090</a:t>
+            </a:r>
+          </a:p>
+          <a:p>
+            <a:pPr>
+              <a:defRPr sz="2000"/>
+            </a:pPr>
+            <a:r>
+              <a:t>Grafana: http://localhost:3000</a:t>
             </a:r>
           </a:p>
         </p:txBody>
@@ -3453,7 +3445,7 @@
           <a:lstStyle/>
           <a:p>
             <a:r>
-              <a:t>Runtime Services and Ports</a:t>
+              <a:t>API Endpoints by Source</a:t>
             </a:r>
           </a:p>
         </p:txBody>
@@ -3477,63 +3469,79 @@
               <a:defRPr sz="2000"/>
             </a:pPr>
             <a:r>
-              <a:t>Ingestion API: http://localhost:8000/api/v1</a:t>
-            </a:r>
-          </a:p>
-          <a:p>
-            <a:pPr>
-              <a:defRPr sz="2000"/>
-            </a:pPr>
-            <a:r>
-              <a:t>Swagger UI: http://localhost:8000/docs</a:t>
-            </a:r>
-          </a:p>
-          <a:p>
-            <a:pPr>
-              <a:defRPr sz="2000"/>
-            </a:pPr>
-            <a:r>
-              <a:t>Health: http://localhost:8000/api/v1/health</a:t>
-            </a:r>
-          </a:p>
-          <a:p>
-            <a:pPr>
-              <a:defRPr sz="2000"/>
-            </a:pPr>
-            <a:r>
-              <a:t>LocalStack: http://localhost:4566</a:t>
-            </a:r>
-          </a:p>
-          <a:p>
-            <a:pPr>
-              <a:defRPr sz="2000"/>
-            </a:pPr>
-            <a:r>
-              <a:t>PostgreSQL: localhost:5432</a:t>
-            </a:r>
-          </a:p>
-          <a:p>
-            <a:pPr>
-              <a:defRPr sz="2000"/>
-            </a:pPr>
-            <a:r>
-              <a:t>pgAdmin: http://localhost:5050</a:t>
-            </a:r>
-          </a:p>
-          <a:p>
-            <a:pPr>
-              <a:defRPr sz="2000"/>
-            </a:pPr>
-            <a:r>
-              <a:t>Prometheus: http://localhost:9090</a:t>
-            </a:r>
-          </a:p>
-          <a:p>
-            <a:pPr>
-              <a:defRPr sz="2000"/>
-            </a:pPr>
-            <a:r>
-              <a:t>Grafana: http://localhost:3000</a:t>
+              <a:t>Ingestion endpoints:</a:t>
+            </a:r>
+          </a:p>
+          <a:p>
+            <a:pPr>
+              <a:defRPr sz="2000"/>
+            </a:pPr>
+            <a:r>
+              <a:t>POST /api/v1/mes/events</a:t>
+            </a:r>
+          </a:p>
+          <a:p>
+            <a:pPr>
+              <a:defRPr sz="2000"/>
+            </a:pPr>
+            <a:r>
+              <a:t>POST /api/v1/erp/events</a:t>
+            </a:r>
+          </a:p>
+          <a:p>
+            <a:pPr>
+              <a:defRPr sz="2000"/>
+            </a:pPr>
+            <a:r>
+              <a:t>POST /api/v1/equipment/events</a:t>
+            </a:r>
+          </a:p>
+          <a:p>
+            <a:pPr>
+              <a:defRPr sz="2000"/>
+            </a:pPr>
+            <a:r>
+              <a:t>POST /api/v1/plm/events</a:t>
+            </a:r>
+          </a:p>
+          <a:p>
+            <a:pPr>
+              <a:defRPr sz="2000"/>
+            </a:pPr>
+            <a:r>
+              <a:t>Operational endpoints:</a:t>
+            </a:r>
+          </a:p>
+          <a:p>
+            <a:pPr>
+              <a:defRPr sz="2000"/>
+            </a:pPr>
+            <a:r>
+              <a:t>GET /api/v1/health</a:t>
+            </a:r>
+          </a:p>
+          <a:p>
+            <a:pPr>
+              <a:defRPr sz="2000"/>
+            </a:pPr>
+            <a:r>
+              <a:t>GET /api/v1/ready</a:t>
+            </a:r>
+          </a:p>
+          <a:p>
+            <a:pPr>
+              <a:defRPr sz="2000"/>
+            </a:pPr>
+            <a:r>
+              <a:t>GET /api/v1/config/sources</a:t>
+            </a:r>
+          </a:p>
+          <a:p>
+            <a:pPr>
+              <a:defRPr sz="2000"/>
+            </a:pPr>
+            <a:r>
+              <a:t>GET /api/v1/config/streams</a:t>
             </a:r>
           </a:p>
         </p:txBody>
@@ -3579,7 +3587,7 @@
           <a:lstStyle/>
           <a:p>
             <a:r>
-              <a:t>API Endpoints by Source</a:t>
+              <a:t>Example Ingestion Response (202)</a:t>
             </a:r>
           </a:p>
         </p:txBody>
@@ -3603,79 +3611,79 @@
               <a:defRPr sz="2000"/>
             </a:pPr>
             <a:r>
-              <a:t>Ingestion endpoints:</a:t>
-            </a:r>
-          </a:p>
-          <a:p>
-            <a:pPr>
-              <a:defRPr sz="2000"/>
-            </a:pPr>
-            <a:r>
-              <a:t>POST /api/v1/mes/events</a:t>
-            </a:r>
-          </a:p>
-          <a:p>
-            <a:pPr>
-              <a:defRPr sz="2000"/>
-            </a:pPr>
-            <a:r>
-              <a:t>POST /api/v1/erp/events</a:t>
-            </a:r>
-          </a:p>
-          <a:p>
-            <a:pPr>
-              <a:defRPr sz="2000"/>
-            </a:pPr>
-            <a:r>
-              <a:t>POST /api/v1/equipment/events</a:t>
-            </a:r>
-          </a:p>
-          <a:p>
-            <a:pPr>
-              <a:defRPr sz="2000"/>
-            </a:pPr>
-            <a:r>
-              <a:t>POST /api/v1/plm/events</a:t>
-            </a:r>
-          </a:p>
-          <a:p>
-            <a:pPr>
-              <a:defRPr sz="2000"/>
-            </a:pPr>
-            <a:r>
-              <a:t>Operational endpoints:</a:t>
-            </a:r>
-          </a:p>
-          <a:p>
-            <a:pPr>
-              <a:defRPr sz="2000"/>
-            </a:pPr>
-            <a:r>
-              <a:t>GET /api/v1/health</a:t>
-            </a:r>
-          </a:p>
-          <a:p>
-            <a:pPr>
-              <a:defRPr sz="2000"/>
-            </a:pPr>
-            <a:r>
-              <a:t>GET /api/v1/ready</a:t>
-            </a:r>
-          </a:p>
-          <a:p>
-            <a:pPr>
-              <a:defRPr sz="2000"/>
-            </a:pPr>
-            <a:r>
-              <a:t>GET /api/v1/config/sources</a:t>
-            </a:r>
-          </a:p>
-          <a:p>
-            <a:pPr>
-              <a:defRPr sz="2000"/>
-            </a:pPr>
-            <a:r>
-              <a:t>GET /api/v1/config/streams</a:t>
+              <a:t>request_id</a:t>
+            </a:r>
+          </a:p>
+          <a:p>
+            <a:pPr>
+              <a:defRPr sz="2000"/>
+            </a:pPr>
+            <a:r>
+              <a:t>source</a:t>
+            </a:r>
+          </a:p>
+          <a:p>
+            <a:pPr>
+              <a:defRPr sz="2000"/>
+            </a:pPr>
+            <a:r>
+              <a:t>status = ACCEPTED</a:t>
+            </a:r>
+          </a:p>
+          <a:p>
+            <a:pPr>
+              <a:defRPr sz="2000"/>
+            </a:pPr>
+            <a:r>
+              <a:t>s3_key</a:t>
+            </a:r>
+          </a:p>
+          <a:p>
+            <a:pPr>
+              <a:defRPr sz="2000"/>
+            </a:pPr>
+            <a:r>
+              <a:t>stream</a:t>
+            </a:r>
+          </a:p>
+          <a:p>
+            <a:pPr>
+              <a:defRPr sz="2000"/>
+            </a:pPr>
+            <a:r>
+              <a:t>sequence_number</a:t>
+            </a:r>
+          </a:p>
+          <a:p>
+            <a:pPr>
+              <a:defRPr sz="2000"/>
+            </a:pPr>
+            <a:r>
+              <a:t>curated_record_id</a:t>
+            </a:r>
+          </a:p>
+          <a:p>
+            <a:pPr>
+              <a:defRPr sz="2000"/>
+            </a:pPr>
+            <a:r>
+              <a:t>Value:</a:t>
+            </a:r>
+          </a:p>
+          <a:p>
+            <a:pPr>
+              <a:defRPr sz="2000"/>
+            </a:pPr>
+            <a:r>
+              <a:t>Immediate operational acknowledgement</a:t>
+            </a:r>
+          </a:p>
+          <a:p>
+            <a:pPr>
+              <a:defRPr sz="2000"/>
+            </a:pPr>
+            <a:r>
+              <a:t>IDs for lineage tracing across storage and streaming</a:t>
             </a:r>
           </a:p>
         </p:txBody>
@@ -3721,7 +3729,7 @@
           <a:lstStyle/>
           <a:p>
             <a:r>
-              <a:t>Example Ingestion Response (202)</a:t>
+              <a:t>Validation and Error Handling</a:t>
             </a:r>
           </a:p>
         </p:txBody>
@@ -3745,79 +3753,31 @@
               <a:defRPr sz="2000"/>
             </a:pPr>
             <a:r>
-              <a:t>request_id</a:t>
-            </a:r>
-          </a:p>
-          <a:p>
-            <a:pPr>
-              <a:defRPr sz="2000"/>
-            </a:pPr>
-            <a:r>
-              <a:t>source</a:t>
-            </a:r>
-          </a:p>
-          <a:p>
-            <a:pPr>
-              <a:defRPr sz="2000"/>
-            </a:pPr>
-            <a:r>
-              <a:t>status = ACCEPTED</a:t>
-            </a:r>
-          </a:p>
-          <a:p>
-            <a:pPr>
-              <a:defRPr sz="2000"/>
-            </a:pPr>
-            <a:r>
-              <a:t>s3_key</a:t>
-            </a:r>
-          </a:p>
-          <a:p>
-            <a:pPr>
-              <a:defRPr sz="2000"/>
-            </a:pPr>
-            <a:r>
-              <a:t>stream</a:t>
-            </a:r>
-          </a:p>
-          <a:p>
-            <a:pPr>
-              <a:defRPr sz="2000"/>
-            </a:pPr>
-            <a:r>
-              <a:t>sequence_number</a:t>
-            </a:r>
-          </a:p>
-          <a:p>
-            <a:pPr>
-              <a:defRPr sz="2000"/>
-            </a:pPr>
-            <a:r>
-              <a:t>curated_record_id</a:t>
-            </a:r>
-          </a:p>
-          <a:p>
-            <a:pPr>
-              <a:defRPr sz="2000"/>
-            </a:pPr>
-            <a:r>
-              <a:t>Value:</a:t>
-            </a:r>
-          </a:p>
-          <a:p>
-            <a:pPr>
-              <a:defRPr sz="2000"/>
-            </a:pPr>
-            <a:r>
-              <a:t>Immediate operational acknowledgement</a:t>
-            </a:r>
-          </a:p>
-          <a:p>
-            <a:pPr>
-              <a:defRPr sz="2000"/>
-            </a:pPr>
-            <a:r>
-              <a:t>IDs for lineage tracing across storage and streaming</a:t>
+              <a:t>Payloads are validated per-source using JSON Schema</a:t>
+            </a:r>
+          </a:p>
+          <a:p>
+            <a:pPr>
+              <a:defRPr sz="2000"/>
+            </a:pPr>
+            <a:r>
+              <a:t>Validation failure returns HTTP 400 with structured errors</a:t>
+            </a:r>
+          </a:p>
+          <a:p>
+            <a:pPr>
+              <a:defRPr sz="2000"/>
+            </a:pPr>
+            <a:r>
+              <a:t>Malformed JSON also returns HTTP 400</a:t>
+            </a:r>
+          </a:p>
+          <a:p>
+            <a:pPr>
+              <a:defRPr sz="2000"/>
+            </a:pPr>
+            <a:r>
+              <a:t>Health endpoint returns component-level statuses and can return 503 when dependencies fail</a:t>
             </a:r>
           </a:p>
         </p:txBody>
@@ -3863,7 +3823,7 @@
           <a:lstStyle/>
           <a:p>
             <a:r>
-              <a:t>Validation and Error Handling</a:t>
+              <a:t>PostgreSQL Data Model</a:t>
             </a:r>
           </a:p>
         </p:txBody>
@@ -3887,31 +3847,63 @@
               <a:defRPr sz="2000"/>
             </a:pPr>
             <a:r>
-              <a:t>Payloads are validated per-source using JSON Schema</a:t>
-            </a:r>
-          </a:p>
-          <a:p>
-            <a:pPr>
-              <a:defRPr sz="2000"/>
-            </a:pPr>
-            <a:r>
-              <a:t>Validation failure returns HTTP 400 with structured errors</a:t>
-            </a:r>
-          </a:p>
-          <a:p>
-            <a:pPr>
-              <a:defRPr sz="2000"/>
-            </a:pPr>
-            <a:r>
-              <a:t>Malformed JSON also returns HTTP 400</a:t>
-            </a:r>
-          </a:p>
-          <a:p>
-            <a:pPr>
-              <a:defRPr sz="2000"/>
-            </a:pPr>
-            <a:r>
-              <a:t>Health endpoint returns component-level statuses and can return 503 when dependencies fail</a:t>
+              <a:t>Schemas:</a:t>
+            </a:r>
+          </a:p>
+          <a:p>
+            <a:pPr>
+              <a:defRPr sz="2000"/>
+            </a:pPr>
+            <a:r>
+              <a:t>mdm</a:t>
+            </a:r>
+          </a:p>
+          <a:p>
+            <a:pPr>
+              <a:defRPr sz="2000"/>
+            </a:pPr>
+            <a:r>
+              <a:t>metadata</a:t>
+            </a:r>
+          </a:p>
+          <a:p>
+            <a:pPr>
+              <a:defRPr sz="2000"/>
+            </a:pPr>
+            <a:r>
+              <a:t>quality (reserved for future use)</a:t>
+            </a:r>
+          </a:p>
+          <a:p>
+            <a:pPr>
+              <a:defRPr sz="2000"/>
+            </a:pPr>
+            <a:r>
+              <a:t>Primary tables:</a:t>
+            </a:r>
+          </a:p>
+          <a:p>
+            <a:pPr>
+              <a:defRPr sz="2000"/>
+            </a:pPr>
+            <a:r>
+              <a:t>mdm.lot_master: curated MES rows</a:t>
+            </a:r>
+          </a:p>
+          <a:p>
+            <a:pPr>
+              <a:defRPr sz="2000"/>
+            </a:pPr>
+            <a:r>
+              <a:t>metadata.raw_events: generic curated rows for ERP/Equipment/PLM</a:t>
+            </a:r>
+          </a:p>
+          <a:p>
+            <a:pPr>
+              <a:defRPr sz="2000"/>
+            </a:pPr>
+            <a:r>
+              <a:t>metadata.ingestion_log: request-level audit log</a:t>
             </a:r>
           </a:p>
         </p:txBody>
@@ -3957,7 +3949,7 @@
           <a:lstStyle/>
           <a:p>
             <a:r>
-              <a:t>PostgreSQL Data Model</a:t>
+              <a:t>Table Relationships and Lineage</a:t>
             </a:r>
           </a:p>
         </p:txBody>
@@ -3981,63 +3973,79 @@
               <a:defRPr sz="2000"/>
             </a:pPr>
             <a:r>
-              <a:t>Schemas:</a:t>
-            </a:r>
-          </a:p>
-          <a:p>
-            <a:pPr>
-              <a:defRPr sz="2000"/>
-            </a:pPr>
-            <a:r>
-              <a:t>mdm</a:t>
-            </a:r>
-          </a:p>
-          <a:p>
-            <a:pPr>
-              <a:defRPr sz="2000"/>
-            </a:pPr>
-            <a:r>
-              <a:t>metadata</a:t>
-            </a:r>
-          </a:p>
-          <a:p>
-            <a:pPr>
-              <a:defRPr sz="2000"/>
-            </a:pPr>
-            <a:r>
-              <a:t>quality (reserved for future use)</a:t>
-            </a:r>
-          </a:p>
-          <a:p>
-            <a:pPr>
-              <a:defRPr sz="2000"/>
-            </a:pPr>
-            <a:r>
-              <a:t>Primary tables:</a:t>
-            </a:r>
-          </a:p>
-          <a:p>
-            <a:pPr>
-              <a:defRPr sz="2000"/>
-            </a:pPr>
-            <a:r>
-              <a:t>mdm.lot_master: curated MES rows</a:t>
-            </a:r>
-          </a:p>
-          <a:p>
-            <a:pPr>
-              <a:defRPr sz="2000"/>
-            </a:pPr>
-            <a:r>
-              <a:t>metadata.raw_events: generic curated rows for ERP/Equipment/PLM</a:t>
-            </a:r>
-          </a:p>
-          <a:p>
-            <a:pPr>
-              <a:defRPr sz="2000"/>
-            </a:pPr>
-            <a:r>
-              <a:t>metadata.ingestion_log: request-level audit log</a:t>
+              <a:t>Current model uses logical relationships (lineage keys), not strict FK constraints.</a:t>
+            </a:r>
+          </a:p>
+          <a:p>
+            <a:pPr>
+              <a:defRPr sz="2000"/>
+            </a:pPr>
+            <a:r>
+              <a:t>Logical linkage signals:</a:t>
+            </a:r>
+          </a:p>
+          <a:p>
+            <a:pPr>
+              <a:defRPr sz="2000"/>
+            </a:pPr>
+            <a:r>
+              <a:t>request_id</a:t>
+            </a:r>
+          </a:p>
+          <a:p>
+            <a:pPr>
+              <a:defRPr sz="2000"/>
+            </a:pPr>
+            <a:r>
+              <a:t>source</a:t>
+            </a:r>
+          </a:p>
+          <a:p>
+            <a:pPr>
+              <a:defRPr sz="2000"/>
+            </a:pPr>
+            <a:r>
+              <a:t>stream</a:t>
+            </a:r>
+          </a:p>
+          <a:p>
+            <a:pPr>
+              <a:defRPr sz="2000"/>
+            </a:pPr>
+            <a:r>
+              <a:t>s3_key</a:t>
+            </a:r>
+          </a:p>
+          <a:p>
+            <a:pPr>
+              <a:defRPr sz="2000"/>
+            </a:pPr>
+            <a:r>
+              <a:t>time ordering</a:t>
+            </a:r>
+          </a:p>
+          <a:p>
+            <a:pPr>
+              <a:defRPr sz="2000"/>
+            </a:pPr>
+            <a:r>
+              <a:t>View:</a:t>
+            </a:r>
+          </a:p>
+          <a:p>
+            <a:pPr>
+              <a:defRPr sz="2000"/>
+            </a:pPr>
+            <a:r>
+              <a:t>metadata.v_ingestion_lineage</a:t>
+            </a:r>
+          </a:p>
+          <a:p>
+            <a:pPr>
+              <a:defRPr sz="2000"/>
+            </a:pPr>
+            <a:r>
+              <a:t>Normalizes request-to-curated mapping for analysis and operations</a:t>
             </a:r>
           </a:p>
         </p:txBody>
@@ -4083,7 +4091,7 @@
           <a:lstStyle/>
           <a:p>
             <a:r>
-              <a:t>Table Relationships and Lineage</a:t>
+              <a:t>Storage and Streaming Strategy</a:t>
             </a:r>
           </a:p>
         </p:txBody>
@@ -4107,79 +4115,79 @@
               <a:defRPr sz="2000"/>
             </a:pPr>
             <a:r>
-              <a:t>Current model uses logical relationships (lineage keys), not strict FK constraints.</a:t>
-            </a:r>
-          </a:p>
-          <a:p>
-            <a:pPr>
-              <a:defRPr sz="2000"/>
-            </a:pPr>
-            <a:r>
-              <a:t>Logical linkage signals:</a:t>
-            </a:r>
-          </a:p>
-          <a:p>
-            <a:pPr>
-              <a:defRPr sz="2000"/>
-            </a:pPr>
-            <a:r>
-              <a:t>request_id</a:t>
-            </a:r>
-          </a:p>
-          <a:p>
-            <a:pPr>
-              <a:defRPr sz="2000"/>
-            </a:pPr>
-            <a:r>
-              <a:t>source</a:t>
-            </a:r>
-          </a:p>
-          <a:p>
-            <a:pPr>
-              <a:defRPr sz="2000"/>
-            </a:pPr>
-            <a:r>
-              <a:t>stream</a:t>
-            </a:r>
-          </a:p>
-          <a:p>
-            <a:pPr>
-              <a:defRPr sz="2000"/>
-            </a:pPr>
-            <a:r>
-              <a:t>s3_key</a:t>
-            </a:r>
-          </a:p>
-          <a:p>
-            <a:pPr>
-              <a:defRPr sz="2000"/>
-            </a:pPr>
-            <a:r>
-              <a:t>time ordering</a:t>
-            </a:r>
-          </a:p>
-          <a:p>
-            <a:pPr>
-              <a:defRPr sz="2000"/>
-            </a:pPr>
-            <a:r>
-              <a:t>View:</a:t>
-            </a:r>
-          </a:p>
-          <a:p>
-            <a:pPr>
-              <a:defRPr sz="2000"/>
-            </a:pPr>
-            <a:r>
-              <a:t>metadata.v_ingestion_lineage</a:t>
-            </a:r>
-          </a:p>
-          <a:p>
-            <a:pPr>
-              <a:defRPr sz="2000"/>
-            </a:pPr>
-            <a:r>
-              <a:t>Normalizes request-to-curated mapping for analysis and operations</a:t>
+              <a:t>S3</a:t>
+            </a:r>
+          </a:p>
+          <a:p>
+            <a:pPr>
+              <a:defRPr sz="2000"/>
+            </a:pPr>
+            <a:r>
+              <a:t>Durable raw payload retention by source prefix</a:t>
+            </a:r>
+          </a:p>
+          <a:p>
+            <a:pPr>
+              <a:defRPr sz="2000"/>
+            </a:pPr>
+            <a:r>
+              <a:t>Supports replay and forensic analysis</a:t>
+            </a:r>
+          </a:p>
+          <a:p>
+            <a:pPr>
+              <a:defRPr sz="2000"/>
+            </a:pPr>
+            <a:r>
+              <a:t>Kinesis</a:t>
+            </a:r>
+          </a:p>
+          <a:p>
+            <a:pPr>
+              <a:defRPr sz="2000"/>
+            </a:pPr>
+            <a:r>
+              <a:t>Event fan-out to downstream consumers</a:t>
+            </a:r>
+          </a:p>
+          <a:p>
+            <a:pPr>
+              <a:defRPr sz="2000"/>
+            </a:pPr>
+            <a:r>
+              <a:t>Streams:</a:t>
+            </a:r>
+          </a:p>
+          <a:p>
+            <a:pPr>
+              <a:defRPr sz="2000"/>
+            </a:pPr>
+            <a:r>
+              <a:t>mes-events</a:t>
+            </a:r>
+          </a:p>
+          <a:p>
+            <a:pPr>
+              <a:defRPr sz="2000"/>
+            </a:pPr>
+            <a:r>
+              <a:t>metadata-events</a:t>
+            </a:r>
+          </a:p>
+          <a:p>
+            <a:pPr>
+              <a:defRPr sz="2000"/>
+            </a:pPr>
+            <a:r>
+              <a:t>quality-events</a:t>
+            </a:r>
+          </a:p>
+          <a:p>
+            <a:pPr>
+              <a:defRPr sz="2000"/>
+            </a:pPr>
+            <a:r>
+              <a:t>plm-events</a:t>
             </a:r>
           </a:p>
         </p:txBody>
@@ -4225,7 +4233,7 @@
           <a:lstStyle/>
           <a:p>
             <a:r>
-              <a:t>Storage and Streaming Strategy</a:t>
+              <a:t>Verification and Operational Scripts</a:t>
             </a:r>
           </a:p>
         </p:txBody>
@@ -4249,80 +4257,121 @@
               <a:defRPr sz="2000"/>
             </a:pPr>
             <a:r>
-              <a:t>S3</a:t>
-            </a:r>
-          </a:p>
-          <a:p>
-            <a:pPr>
-              <a:defRPr sz="2000"/>
-            </a:pPr>
-            <a:r>
-              <a:t>Durable raw payload retention by source prefix</a:t>
-            </a:r>
-          </a:p>
-          <a:p>
-            <a:pPr>
-              <a:defRPr sz="2000"/>
-            </a:pPr>
-            <a:r>
-              <a:t>Supports replay and forensic analysis</a:t>
-            </a:r>
-          </a:p>
-          <a:p>
-            <a:pPr>
-              <a:defRPr sz="2000"/>
-            </a:pPr>
-            <a:r>
-              <a:t>Kinesis</a:t>
-            </a:r>
-          </a:p>
-          <a:p>
-            <a:pPr>
-              <a:defRPr sz="2000"/>
-            </a:pPr>
-            <a:r>
-              <a:t>Event fan-out to downstream consumers</a:t>
-            </a:r>
-          </a:p>
-          <a:p>
-            <a:pPr>
-              <a:defRPr sz="2000"/>
-            </a:pPr>
-            <a:r>
-              <a:t>Streams:</a:t>
-            </a:r>
-          </a:p>
-          <a:p>
-            <a:pPr>
-              <a:defRPr sz="2000"/>
-            </a:pPr>
-            <a:r>
-              <a:t>mes-events</a:t>
-            </a:r>
-          </a:p>
-          <a:p>
-            <a:pPr>
-              <a:defRPr sz="2000"/>
-            </a:pPr>
-            <a:r>
-              <a:t>metadata-events</a:t>
-            </a:r>
-          </a:p>
-          <a:p>
-            <a:pPr>
-              <a:defRPr sz="2000"/>
-            </a:pPr>
-            <a:r>
-              <a:t>quality-events</a:t>
-            </a:r>
-          </a:p>
-          <a:p>
-            <a:pPr>
-              <a:defRPr sz="2000"/>
-            </a:pPr>
-            <a:r>
-              <a:t>plm-events</a:t>
-            </a:r>
+              <a:rPr dirty="0"/>
+              <a:t>scripts/verify_pipeline.ps1</a:t>
+            </a:r>
+          </a:p>
+          <a:p>
+            <a:pPr>
+              <a:defRPr sz="2000"/>
+            </a:pPr>
+            <a:r>
+              <a:rPr dirty="0"/>
+              <a:t>Supports all-source verification mode</a:t>
+            </a:r>
+          </a:p>
+          <a:p>
+            <a:pPr>
+              <a:defRPr sz="2000"/>
+            </a:pPr>
+            <a:r>
+              <a:rPr dirty="0"/>
+              <a:t>Can ingest samples and validate API, S3, Kinesis, and Postgres</a:t>
+            </a:r>
+          </a:p>
+          <a:p>
+            <a:pPr>
+              <a:defRPr sz="2000"/>
+            </a:pPr>
+            <a:r>
+              <a:rPr dirty="0"/>
+              <a:t>Auto-writes results to docs/end_to_end_test_result.md</a:t>
+            </a:r>
+          </a:p>
+          <a:p>
+            <a:pPr>
+              <a:defRPr sz="2000"/>
+            </a:pPr>
+            <a:r>
+              <a:rPr dirty="0"/>
+              <a:t>scripts/</a:t>
+            </a:r>
+            <a:r>
+              <a:rPr dirty="0" err="1"/>
+              <a:t>sql</a:t>
+            </a:r>
+            <a:r>
+              <a:rPr dirty="0"/>
+              <a:t>/</a:t>
+            </a:r>
+            <a:r>
+              <a:rPr dirty="0" err="1"/>
+              <a:t>postgres_table_queries.sql</a:t>
+            </a:r>
+            <a:endParaRPr dirty="0"/>
+          </a:p>
+          <a:p>
+            <a:pPr>
+              <a:defRPr sz="2000"/>
+            </a:pPr>
+            <a:r>
+              <a:rPr dirty="0"/>
+              <a:t>Counts, recent rows, lineage queries</a:t>
+            </a:r>
+          </a:p>
+          <a:p>
+            <a:pPr>
+              <a:defRPr sz="2000"/>
+            </a:pPr>
+            <a:r>
+              <a:rPr dirty="0"/>
+              <a:t>scripts/</a:t>
+            </a:r>
+            <a:r>
+              <a:rPr dirty="0" err="1"/>
+              <a:t>sql</a:t>
+            </a:r>
+            <a:r>
+              <a:rPr dirty="0"/>
+              <a:t>/</a:t>
+            </a:r>
+            <a:r>
+              <a:rPr dirty="0" err="1"/>
+              <a:t>postgres_delete_rows.sql</a:t>
+            </a:r>
+            <a:endParaRPr dirty="0"/>
+          </a:p>
+          <a:p>
+            <a:pPr>
+              <a:defRPr sz="2000"/>
+            </a:pPr>
+            <a:r>
+              <a:rPr dirty="0"/>
+              <a:t>scripts/</a:t>
+            </a:r>
+            <a:r>
+              <a:rPr dirty="0" err="1"/>
+              <a:t>sql</a:t>
+            </a:r>
+            <a:r>
+              <a:rPr dirty="0"/>
+              <a:t>/</a:t>
+            </a:r>
+            <a:r>
+              <a:rPr dirty="0" err="1"/>
+              <a:t>postgres_insert_rows.sql</a:t>
+            </a:r>
+            <a:endParaRPr lang="en-IN" dirty="0"/>
+          </a:p>
+          <a:p>
+            <a:pPr>
+              <a:defRPr sz="2000"/>
+            </a:pPr>
+            <a:r>
+              <a:rPr lang="en-IN" dirty="0"/>
+              <a:t>scripts/smoke_test.sh</a:t>
+            </a:r>
+            <a:endParaRPr dirty="0"/>
           </a:p>
         </p:txBody>
       </p:sp>
@@ -4367,7 +4416,7 @@
           <a:lstStyle/>
           <a:p>
             <a:r>
-              <a:t>Verification and Operational Scripts</a:t>
+              <a:t>Testing Strategy</a:t>
             </a:r>
           </a:p>
         </p:txBody>
@@ -4387,67 +4436,92 @@
           <a:bodyPr/>
           <a:lstStyle/>
           <a:p>
-            <a:pPr>
-              <a:defRPr sz="2000"/>
-            </a:pPr>
-            <a:r>
-              <a:t>scripts/verify_pipeline.ps1</a:t>
-            </a:r>
-          </a:p>
-          <a:p>
-            <a:pPr>
-              <a:defRPr sz="2000"/>
-            </a:pPr>
-            <a:r>
-              <a:t>Supports all-source verification mode</a:t>
-            </a:r>
-          </a:p>
-          <a:p>
-            <a:pPr>
-              <a:defRPr sz="2000"/>
-            </a:pPr>
-            <a:r>
-              <a:t>Can ingest samples and validate API, S3, Kinesis, and Postgres</a:t>
-            </a:r>
-          </a:p>
-          <a:p>
-            <a:pPr>
-              <a:defRPr sz="2000"/>
-            </a:pPr>
-            <a:r>
-              <a:t>Auto-writes results to docs/end_to_end_test_result.md</a:t>
-            </a:r>
-          </a:p>
-          <a:p>
-            <a:pPr>
-              <a:defRPr sz="2000"/>
-            </a:pPr>
-            <a:r>
-              <a:t>scripts/sql/postgres_table_queries.sql</a:t>
-            </a:r>
-          </a:p>
-          <a:p>
-            <a:pPr>
-              <a:defRPr sz="2000"/>
-            </a:pPr>
-            <a:r>
-              <a:t>Counts, recent rows, lineage queries</a:t>
-            </a:r>
-          </a:p>
-          <a:p>
-            <a:pPr>
-              <a:defRPr sz="2000"/>
-            </a:pPr>
-            <a:r>
-              <a:t>scripts/sql/postgres_delete_rows.sql</a:t>
-            </a:r>
-          </a:p>
-          <a:p>
-            <a:pPr>
-              <a:defRPr sz="2000"/>
-            </a:pPr>
-            <a:r>
-              <a:t>scripts/sql/postgres_insert_rows.sql</a:t>
+            <a:pPr marL="0" indent="0">
+              <a:buNone/>
+              <a:defRPr sz="2000"/>
+            </a:pPr>
+            <a:r>
+              <a:rPr dirty="0"/>
+              <a:t>Offline-friendly tests with moto and in-memory SQLite</a:t>
+            </a:r>
+          </a:p>
+          <a:p>
+            <a:pPr marL="0" indent="0">
+              <a:buNone/>
+              <a:defRPr sz="2000"/>
+            </a:pPr>
+            <a:endParaRPr lang="en-IN" dirty="0"/>
+          </a:p>
+          <a:p>
+            <a:pPr marL="0" indent="0">
+              <a:buNone/>
+              <a:defRPr sz="2000"/>
+            </a:pPr>
+            <a:r>
+              <a:rPr dirty="0"/>
+              <a:t>Coverage includes:</a:t>
+            </a:r>
+          </a:p>
+          <a:p>
+            <a:pPr>
+              <a:defRPr sz="2000"/>
+            </a:pPr>
+            <a:r>
+              <a:rPr dirty="0"/>
+              <a:t>schema validation</a:t>
+            </a:r>
+          </a:p>
+          <a:p>
+            <a:pPr>
+              <a:defRPr sz="2000"/>
+            </a:pPr>
+            <a:r>
+              <a:rPr dirty="0"/>
+              <a:t>API success and failure paths</a:t>
+            </a:r>
+          </a:p>
+          <a:p>
+            <a:pPr>
+              <a:defRPr sz="2000"/>
+            </a:pPr>
+            <a:r>
+              <a:rPr dirty="0"/>
+              <a:t>repository behavior</a:t>
+            </a:r>
+          </a:p>
+          <a:p>
+            <a:pPr>
+              <a:defRPr sz="2000"/>
+            </a:pPr>
+            <a:r>
+              <a:rPr dirty="0"/>
+              <a:t>S3 and Kinesis integration abstractions</a:t>
+            </a:r>
+          </a:p>
+          <a:p>
+            <a:pPr>
+              <a:defRPr sz="2000"/>
+            </a:pPr>
+            <a:r>
+              <a:rPr dirty="0"/>
+              <a:t>configuration loading</a:t>
+            </a:r>
+          </a:p>
+          <a:p>
+            <a:pPr>
+              <a:defRPr sz="2000"/>
+            </a:pPr>
+            <a:r>
+              <a:rPr dirty="0"/>
+              <a:t>Operational testing also available via </a:t>
+            </a:r>
+            <a:r>
+              <a:rPr dirty="0" err="1"/>
+              <a:t>dockerized</a:t>
+            </a:r>
+            <a:r>
+              <a:rPr dirty="0"/>
+              <a:t> runtime checks.</a:t>
             </a:r>
           </a:p>
         </p:txBody>
@@ -4465,7 +4539,13 @@
   <p:cSld>
     <p:spTree>
       <p:nvGrpSpPr>
-        <p:cNvPr id="1" name=""/>
+        <p:cNvPr id="1" name="">
+          <a:extLst>
+            <a:ext uri="{FF2B5EF4-FFF2-40B4-BE49-F238E27FC236}">
+              <a16:creationId xmlns:a16="http://schemas.microsoft.com/office/drawing/2014/main" id="{D50929CE-AF75-D63A-0834-0E6862410CD6}"/>
+            </a:ext>
+          </a:extLst>
+        </p:cNvPr>
         <p:cNvGrpSpPr/>
         <p:nvPr/>
       </p:nvGrpSpPr>
@@ -4479,7 +4559,13 @@
       </p:grpSpPr>
       <p:sp>
         <p:nvSpPr>
-          <p:cNvPr id="2" name="Title 1"/>
+          <p:cNvPr id="2" name="Title 1">
+            <a:extLst>
+              <a:ext uri="{FF2B5EF4-FFF2-40B4-BE49-F238E27FC236}">
+                <a16:creationId xmlns:a16="http://schemas.microsoft.com/office/drawing/2014/main" id="{F2C0141E-F7A6-B8A6-DCA2-D2A51237E68F}"/>
+              </a:ext>
+            </a:extLst>
+          </p:cNvPr>
           <p:cNvSpPr>
             <a:spLocks noGrp="1"/>
           </p:cNvSpPr>
@@ -4489,18 +4575,28 @@
         </p:nvSpPr>
         <p:spPr/>
         <p:txBody>
-          <a:bodyPr/>
-          <a:lstStyle/>
-          <a:p>
-            <a:r>
-              <a:t>Testing Strategy</a:t>
-            </a:r>
-          </a:p>
-        </p:txBody>
-      </p:sp>
-      <p:sp>
-        <p:nvSpPr>
-          <p:cNvPr id="3" name="Content Placeholder 2"/>
+          <a:bodyPr>
+            <a:normAutofit/>
+          </a:bodyPr>
+          <a:lstStyle/>
+          <a:p>
+            <a:r>
+              <a:rPr lang="en-IN" dirty="0"/>
+              <a:t>Testing and Results</a:t>
+            </a:r>
+            <a:endParaRPr dirty="0"/>
+          </a:p>
+        </p:txBody>
+      </p:sp>
+      <p:sp>
+        <p:nvSpPr>
+          <p:cNvPr id="3" name="Content Placeholder 2">
+            <a:extLst>
+              <a:ext uri="{FF2B5EF4-FFF2-40B4-BE49-F238E27FC236}">
+                <a16:creationId xmlns:a16="http://schemas.microsoft.com/office/drawing/2014/main" id="{9CAC051F-706D-D7E5-D6D4-5CC6D45E5CBC}"/>
+              </a:ext>
+            </a:extLst>
+          </p:cNvPr>
           <p:cNvSpPr>
             <a:spLocks noGrp="1"/>
           </p:cNvSpPr>
@@ -4508,77 +4604,187 @@
             <p:ph idx="1"/>
           </p:nvPr>
         </p:nvSpPr>
-        <p:spPr/>
-        <p:txBody>
-          <a:bodyPr/>
-          <a:lstStyle/>
-          <a:p>
-            <a:pPr>
-              <a:defRPr sz="2000"/>
-            </a:pPr>
-            <a:r>
-              <a:t>Offline-friendly tests with moto and in-memory SQLite</a:t>
-            </a:r>
-          </a:p>
-          <a:p>
-            <a:pPr>
-              <a:defRPr sz="2000"/>
-            </a:pPr>
-            <a:r>
-              <a:t>Coverage includes:</a:t>
-            </a:r>
-          </a:p>
-          <a:p>
-            <a:pPr>
-              <a:defRPr sz="2000"/>
-            </a:pPr>
-            <a:r>
-              <a:t>schema validation</a:t>
-            </a:r>
-          </a:p>
-          <a:p>
-            <a:pPr>
-              <a:defRPr sz="2000"/>
-            </a:pPr>
-            <a:r>
-              <a:t>API success and failure paths</a:t>
-            </a:r>
-          </a:p>
-          <a:p>
-            <a:pPr>
-              <a:defRPr sz="2000"/>
-            </a:pPr>
-            <a:r>
-              <a:t>repository behavior</a:t>
-            </a:r>
-          </a:p>
-          <a:p>
-            <a:pPr>
-              <a:defRPr sz="2000"/>
-            </a:pPr>
-            <a:r>
-              <a:t>S3 and Kinesis integration abstractions</a:t>
-            </a:r>
-          </a:p>
-          <a:p>
-            <a:pPr>
-              <a:defRPr sz="2000"/>
-            </a:pPr>
-            <a:r>
-              <a:t>configuration loading</a:t>
-            </a:r>
-          </a:p>
-          <a:p>
-            <a:pPr>
-              <a:defRPr sz="2000"/>
-            </a:pPr>
-            <a:r>
-              <a:t>Operational testing also available via dockerized runtime checks.</a:t>
+        <p:spPr>
+          <a:xfrm>
+            <a:off x="457199" y="1492048"/>
+            <a:ext cx="8490155" cy="4983162"/>
+          </a:xfrm>
+        </p:spPr>
+        <p:txBody>
+          <a:bodyPr>
+            <a:noAutofit/>
+          </a:bodyPr>
+          <a:lstStyle/>
+          <a:p>
+            <a:pPr marL="0" indent="0">
+              <a:buNone/>
+            </a:pPr>
+            <a:r>
+              <a:rPr lang="en-IN" sz="1600" b="1" dirty="0"/>
+              <a:t>Categories and Typical Formats Covered</a:t>
+            </a:r>
+            <a:endParaRPr lang="en-IN" sz="1600" dirty="0"/>
+          </a:p>
+          <a:p>
+            <a:pPr marL="0" indent="0">
+              <a:buNone/>
+            </a:pPr>
+            <a:r>
+              <a:rPr lang="en-IN" sz="1600" dirty="0"/>
+              <a:t>- telemetry: </a:t>
+            </a:r>
+            <a:r>
+              <a:rPr lang="en-IN" sz="1600" dirty="0" err="1"/>
+              <a:t>Protobuf</a:t>
+            </a:r>
+            <a:r>
+              <a:rPr lang="en-IN" sz="1600" dirty="0"/>
+              <a:t>, MQTT, Avro, </a:t>
+            </a:r>
+            <a:r>
+              <a:rPr lang="en-IN" sz="1600" dirty="0" err="1"/>
+              <a:t>gRPC</a:t>
+            </a:r>
+            <a:endParaRPr lang="en-IN" sz="1600" dirty="0"/>
+          </a:p>
+          <a:p>
+            <a:pPr marL="0" indent="0">
+              <a:buNone/>
+            </a:pPr>
+            <a:r>
+              <a:rPr lang="en-IN" sz="1600" dirty="0"/>
+              <a:t>- </a:t>
+            </a:r>
+            <a:r>
+              <a:rPr lang="en-IN" sz="1600" dirty="0" err="1"/>
+              <a:t>system_health</a:t>
+            </a:r>
+            <a:r>
+              <a:rPr lang="en-IN" sz="1600" dirty="0"/>
+              <a:t>: JSON, REST, XML</a:t>
+            </a:r>
+          </a:p>
+          <a:p>
+            <a:pPr marL="0" indent="0">
+              <a:buNone/>
+            </a:pPr>
+            <a:r>
+              <a:rPr lang="en-IN" sz="1600" dirty="0"/>
+              <a:t>- logs: Syslog, JSON Logs, Text</a:t>
+            </a:r>
+          </a:p>
+          <a:p>
+            <a:pPr marL="0" indent="0">
+              <a:buNone/>
+            </a:pPr>
+            <a:r>
+              <a:rPr lang="en-IN" sz="1600" dirty="0"/>
+              <a:t>- events: JSON, Kafka, MQTT</a:t>
+            </a:r>
+          </a:p>
+          <a:p>
+            <a:pPr marL="0" indent="0">
+              <a:buNone/>
+            </a:pPr>
+            <a:r>
+              <a:rPr lang="en-IN" sz="1600" dirty="0"/>
+              <a:t>- configuration: YAML, JSON, XML</a:t>
+            </a:r>
+          </a:p>
+          <a:p>
+            <a:pPr marL="0" indent="0">
+              <a:buNone/>
+            </a:pPr>
+            <a:r>
+              <a:rPr lang="en-IN" sz="1600" dirty="0"/>
+              <a:t>- performance: Parquet, CSV</a:t>
+            </a:r>
+          </a:p>
+          <a:p>
+            <a:pPr marL="0" indent="0">
+              <a:buNone/>
+            </a:pPr>
+            <a:r>
+              <a:rPr lang="en-IN" sz="1600" dirty="0"/>
+              <a:t>- validation: CSV, HDF5, XML</a:t>
+            </a:r>
+          </a:p>
+          <a:p>
+            <a:pPr marL="0" indent="0">
+              <a:buNone/>
+            </a:pPr>
+            <a:r>
+              <a:rPr lang="en-IN" sz="1600" dirty="0"/>
+              <a:t>- environmental: MQTT, JSON</a:t>
+            </a:r>
+          </a:p>
+          <a:p>
+            <a:pPr marL="0" indent="0">
+              <a:buNone/>
+            </a:pPr>
+            <a:r>
+              <a:rPr lang="en-IN" sz="1600" dirty="0"/>
+              <a:t>- design: Verilog, GDSII, LEF/DEF</a:t>
+            </a:r>
+          </a:p>
+          <a:p>
+            <a:pPr marL="0" indent="0">
+              <a:buNone/>
+            </a:pPr>
+            <a:r>
+              <a:rPr lang="en-IN" sz="1600" dirty="0"/>
+              <a:t>- manufacturing: STDF, SECS/GEM, OPC-UA</a:t>
+            </a:r>
+          </a:p>
+          <a:p>
+            <a:pPr marL="0" indent="0">
+              <a:buNone/>
+            </a:pPr>
+            <a:endParaRPr lang="en-IN" sz="1600" b="1" dirty="0"/>
+          </a:p>
+          <a:p>
+            <a:pPr marL="0" indent="0">
+              <a:buNone/>
+            </a:pPr>
+            <a:r>
+              <a:rPr lang="en-IN" sz="1600" b="1" dirty="0"/>
+              <a:t>Executable </a:t>
+            </a:r>
+            <a:r>
+              <a:rPr lang="en-IN" sz="1600" b="1" dirty="0" err="1"/>
+              <a:t>powershell</a:t>
+            </a:r>
+            <a:r>
+              <a:rPr lang="en-IN" sz="1600" b="1" dirty="0"/>
+              <a:t> command for testing</a:t>
+            </a:r>
+            <a:endParaRPr lang="en-IN" sz="1600" dirty="0"/>
+          </a:p>
+          <a:p>
+            <a:pPr marL="0" indent="0">
+              <a:buNone/>
+            </a:pPr>
+            <a:r>
+              <a:rPr lang="en-IN" sz="1600" dirty="0"/>
+              <a:t>c:/Users/ravik/rkpy/Semiconductor_Operations_Data_Platform/.venv/Scripts/python.exe -m </a:t>
+            </a:r>
+            <a:r>
+              <a:rPr lang="en-IN" sz="1600" dirty="0" err="1"/>
+              <a:t>pytest</a:t>
+            </a:r>
+            <a:r>
+              <a:rPr lang="en-IN" sz="1600" dirty="0"/>
+              <a:t> tests/test_data_categories_metadata.py tests/test_multiformat_samples.py tests/test_schema_validation.py -q</a:t>
             </a:r>
           </a:p>
         </p:txBody>
       </p:sp>
     </p:spTree>
+    <p:extLst>
+      <p:ext uri="{BB962C8B-B14F-4D97-AF65-F5344CB8AC3E}">
+        <p14:creationId xmlns:p14="http://schemas.microsoft.com/office/powerpoint/2010/main" val="3660186867"/>
+      </p:ext>
+    </p:extLst>
   </p:cSld>
   <p:clrMapOvr>
     <a:masterClrMapping/>
@@ -4745,8 +4951,14 @@
           <a:lstStyle/>
           <a:p>
             <a:r>
-              <a:t>Demo Flow (Recommended)</a:t>
-            </a:r>
+              <a:rPr dirty="0"/>
+              <a:t>Demo Flo</a:t>
+            </a:r>
+            <a:r>
+              <a:rPr lang="en-IN" dirty="0"/>
+              <a:t>w</a:t>
+            </a:r>
+            <a:endParaRPr dirty="0"/>
           </a:p>
         </p:txBody>
       </p:sp>
@@ -4769,6 +4981,7 @@
               <a:defRPr sz="2000"/>
             </a:pPr>
             <a:r>
+              <a:rPr dirty="0"/>
               <a:t>Start stack: docker compose up --build</a:t>
             </a:r>
           </a:p>
@@ -4777,6 +4990,7 @@
               <a:defRPr sz="2000"/>
             </a:pPr>
             <a:r>
+              <a:rPr dirty="0"/>
               <a:t>Open docs UI: /docs</a:t>
             </a:r>
           </a:p>
@@ -4785,6 +4999,7 @@
               <a:defRPr sz="2000"/>
             </a:pPr>
             <a:r>
+              <a:rPr dirty="0"/>
               <a:t>Post sample events for MES, ERP, Equipment, PLM</a:t>
             </a:r>
           </a:p>
@@ -4793,6 +5008,7 @@
               <a:defRPr sz="2000"/>
             </a:pPr>
             <a:r>
+              <a:rPr dirty="0"/>
               <a:t>Verify S3 objects by source prefix</a:t>
             </a:r>
           </a:p>
@@ -4801,6 +5017,7 @@
               <a:defRPr sz="2000"/>
             </a:pPr>
             <a:r>
+              <a:rPr dirty="0"/>
               <a:t>Read Kinesis records per stream</a:t>
             </a:r>
           </a:p>
@@ -4809,14 +5026,21 @@
               <a:defRPr sz="2000"/>
             </a:pPr>
             <a:r>
-              <a:t>Query PostgreSQL tables and metadata.v_ingestion_lineage</a:t>
-            </a:r>
-          </a:p>
-          <a:p>
-            <a:pPr>
-              <a:defRPr sz="2000"/>
-            </a:pPr>
-            <a:r>
+              <a:rPr dirty="0"/>
+              <a:t>Query PostgreSQL tables and </a:t>
+            </a:r>
+            <a:r>
+              <a:rPr dirty="0" err="1"/>
+              <a:t>metadata.v_ingestion_lineage</a:t>
+            </a:r>
+            <a:endParaRPr dirty="0"/>
+          </a:p>
+          <a:p>
+            <a:pPr>
+              <a:defRPr sz="2000"/>
+            </a:pPr>
+            <a:r>
+              <a:rPr dirty="0"/>
               <a:t>Run end-to-end verifier and review markdown report</a:t>
             </a:r>
           </a:p>
@@ -4989,6 +5213,7 @@
               <a:defRPr sz="2000"/>
             </a:pPr>
             <a:r>
+              <a:rPr dirty="0"/>
               <a:t>Endpoints active for MES, ERP, Equipment, PLM</a:t>
             </a:r>
           </a:p>
@@ -4997,6 +5222,7 @@
               <a:defRPr sz="2000"/>
             </a:pPr>
             <a:r>
+              <a:rPr dirty="0"/>
               <a:t>Source-specific sample payloads and schema validation in place</a:t>
             </a:r>
           </a:p>
@@ -5005,22 +5231,34 @@
               <a:defRPr sz="2000"/>
             </a:pPr>
             <a:r>
-              <a:t>LocalStack streams and S3 buckets provisioned</a:t>
-            </a:r>
-          </a:p>
-          <a:p>
-            <a:pPr>
-              <a:defRPr sz="2000"/>
-            </a:pPr>
-            <a:r>
-              <a:t>Postgres lineage view implemented and queryable</a:t>
-            </a:r>
-          </a:p>
-          <a:p>
-            <a:pPr>
-              <a:defRPr sz="2000"/>
-            </a:pPr>
-            <a:r>
+              <a:rPr dirty="0" err="1"/>
+              <a:t>LocalStack</a:t>
+            </a:r>
+            <a:r>
+              <a:rPr dirty="0"/>
+              <a:t> streams and S3 buckets provisioned</a:t>
+            </a:r>
+          </a:p>
+          <a:p>
+            <a:pPr>
+              <a:defRPr sz="2000"/>
+            </a:pPr>
+            <a:r>
+              <a:rPr dirty="0"/>
+              <a:t>Postgres lineage view implemented and </a:t>
+            </a:r>
+            <a:r>
+              <a:rPr dirty="0" err="1"/>
+              <a:t>queryable</a:t>
+            </a:r>
+            <a:endParaRPr dirty="0"/>
+          </a:p>
+          <a:p>
+            <a:pPr>
+              <a:defRPr sz="2000"/>
+            </a:pPr>
+            <a:r>
+              <a:rPr dirty="0"/>
               <a:t>End-to-end verification script passing</a:t>
             </a:r>
           </a:p>
@@ -5838,7 +6076,7 @@
           <a:lstStyle/>
           <a:p>
             <a:r>
-              <a:t>Why Integrate All Four</a:t>
+              <a:t>Architecture Overview</a:t>
             </a:r>
           </a:p>
         </p:txBody>
@@ -5862,47 +6100,63 @@
               <a:defRPr sz="2000"/>
             </a:pPr>
             <a:r>
-              <a:t>MES + Equipment: execution truth and process behavior</a:t>
-            </a:r>
-          </a:p>
-          <a:p>
-            <a:pPr>
-              <a:defRPr sz="2000"/>
-            </a:pPr>
-            <a:r>
-              <a:t>ERP: supply-demand-business alignment</a:t>
-            </a:r>
-          </a:p>
-          <a:p>
-            <a:pPr>
-              <a:defRPr sz="2000"/>
-            </a:pPr>
-            <a:r>
-              <a:t>PLM: engineering and configuration correctness</a:t>
-            </a:r>
-          </a:p>
-          <a:p>
-            <a:pPr>
-              <a:defRPr sz="2000"/>
-            </a:pPr>
-            <a:r>
-              <a:t>Together:</a:t>
-            </a:r>
-          </a:p>
-          <a:p>
-            <a:pPr>
-              <a:defRPr sz="2000"/>
-            </a:pPr>
-            <a:r>
-              <a:t>End-to-end traceability from engineering change to production to delivery</a:t>
-            </a:r>
-          </a:p>
-          <a:p>
-            <a:pPr>
-              <a:defRPr sz="2000"/>
-            </a:pPr>
-            <a:r>
-              <a:t>Better yield protection, faster cycle-time decisions, lower operational risk</a:t>
+              <a:t>Incoming REST Request</a:t>
+            </a:r>
+          </a:p>
+          <a:p>
+            <a:pPr>
+              <a:defRPr sz="2000"/>
+            </a:pPr>
+            <a:r>
+              <a:t>Load metadata from metadata/sources.yaml</a:t>
+            </a:r>
+          </a:p>
+          <a:p>
+            <a:pPr>
+              <a:defRPr sz="2000"/>
+            </a:pPr>
+            <a:r>
+              <a:t>Load schema from schemas/source</a:t>
+            </a:r>
+          </a:p>
+          <a:p>
+            <a:pPr>
+              <a:defRPr sz="2000"/>
+            </a:pPr>
+            <a:r>
+              <a:t>Validate payload (400 on failure)</a:t>
+            </a:r>
+          </a:p>
+          <a:p>
+            <a:pPr>
+              <a:defRPr sz="2000"/>
+            </a:pPr>
+            <a:r>
+              <a:t>Persist raw payload to S3 (LocalStack)</a:t>
+            </a:r>
+          </a:p>
+          <a:p>
+            <a:pPr>
+              <a:defRPr sz="2000"/>
+            </a:pPr>
+            <a:r>
+              <a:t>Publish event to Kinesis (LocalStack)</a:t>
+            </a:r>
+          </a:p>
+          <a:p>
+            <a:pPr>
+              <a:defRPr sz="2000"/>
+            </a:pPr>
+            <a:r>
+              <a:t>Insert curated record into PostgreSQL</a:t>
+            </a:r>
+          </a:p>
+          <a:p>
+            <a:pPr>
+              <a:defRPr sz="2000"/>
+            </a:pPr>
+            <a:r>
+              <a:t>Return HTTP 202 Accepted</a:t>
             </a:r>
           </a:p>
         </p:txBody>
@@ -5948,7 +6202,7 @@
           <a:lstStyle/>
           <a:p>
             <a:r>
-              <a:t>Architecture Overview</a:t>
+              <a:t>Metadata-Driven Design</a:t>
             </a:r>
           </a:p>
         </p:txBody>
@@ -5972,63 +6226,71 @@
               <a:defRPr sz="2000"/>
             </a:pPr>
             <a:r>
-              <a:t>Incoming REST Request</a:t>
-            </a:r>
-          </a:p>
-          <a:p>
-            <a:pPr>
-              <a:defRPr sz="2000"/>
-            </a:pPr>
-            <a:r>
-              <a:t>Load metadata from metadata/sources.yaml</a:t>
-            </a:r>
-          </a:p>
-          <a:p>
-            <a:pPr>
-              <a:defRPr sz="2000"/>
-            </a:pPr>
-            <a:r>
-              <a:t>Load schema from schemas/source</a:t>
-            </a:r>
-          </a:p>
-          <a:p>
-            <a:pPr>
-              <a:defRPr sz="2000"/>
-            </a:pPr>
-            <a:r>
-              <a:t>Validate payload (400 on failure)</a:t>
-            </a:r>
-          </a:p>
-          <a:p>
-            <a:pPr>
-              <a:defRPr sz="2000"/>
-            </a:pPr>
-            <a:r>
-              <a:t>Persist raw payload to S3 (LocalStack)</a:t>
-            </a:r>
-          </a:p>
-          <a:p>
-            <a:pPr>
-              <a:defRPr sz="2000"/>
-            </a:pPr>
-            <a:r>
-              <a:t>Publish event to Kinesis (LocalStack)</a:t>
-            </a:r>
-          </a:p>
-          <a:p>
-            <a:pPr>
-              <a:defRPr sz="2000"/>
-            </a:pPr>
-            <a:r>
-              <a:t>Insert curated record into PostgreSQL</a:t>
-            </a:r>
-          </a:p>
-          <a:p>
-            <a:pPr>
-              <a:defRPr sz="2000"/>
-            </a:pPr>
-            <a:r>
-              <a:t>Return HTTP 202 Accepted</a:t>
+              <a:t>Core metadata files:</a:t>
+            </a:r>
+          </a:p>
+          <a:p>
+            <a:pPr>
+              <a:defRPr sz="2000"/>
+            </a:pPr>
+            <a:r>
+              <a:t>metadata/sources.yaml</a:t>
+            </a:r>
+          </a:p>
+          <a:p>
+            <a:pPr>
+              <a:defRPr sz="2000"/>
+            </a:pPr>
+            <a:r>
+              <a:t>metadata/mappings.yaml</a:t>
+            </a:r>
+          </a:p>
+          <a:p>
+            <a:pPr>
+              <a:defRPr sz="2000"/>
+            </a:pPr>
+            <a:r>
+              <a:t>metadata/routing.yaml</a:t>
+            </a:r>
+          </a:p>
+          <a:p>
+            <a:pPr>
+              <a:defRPr sz="2000"/>
+            </a:pPr>
+            <a:r>
+              <a:t>metadata/validation.yaml</a:t>
+            </a:r>
+          </a:p>
+          <a:p>
+            <a:pPr>
+              <a:defRPr sz="2000"/>
+            </a:pPr>
+            <a:r>
+              <a:t>metadata/streams.yaml</a:t>
+            </a:r>
+          </a:p>
+          <a:p>
+            <a:pPr>
+              <a:defRPr sz="2000"/>
+            </a:pPr>
+            <a:r>
+              <a:t>Principle:</a:t>
+            </a:r>
+          </a:p>
+          <a:p>
+            <a:pPr>
+              <a:defRPr sz="2000"/>
+            </a:pPr>
+            <a:r>
+              <a:t>New source onboarding is primarily metadata and schema updates</a:t>
+            </a:r>
+          </a:p>
+          <a:p>
+            <a:pPr>
+              <a:defRPr sz="2000"/>
+            </a:pPr>
+            <a:r>
+              <a:t>Minimal to no endpoint-handler code changes required</a:t>
             </a:r>
           </a:p>
         </p:txBody>
@@ -6074,7 +6336,7 @@
           <a:lstStyle/>
           <a:p>
             <a:r>
-              <a:t>Metadata-Driven Design</a:t>
+              <a:t>Technology Stack</a:t>
             </a:r>
           </a:p>
         </p:txBody>
@@ -6098,71 +6360,87 @@
               <a:defRPr sz="2000"/>
             </a:pPr>
             <a:r>
-              <a:t>Core metadata files:</a:t>
-            </a:r>
-          </a:p>
-          <a:p>
-            <a:pPr>
-              <a:defRPr sz="2000"/>
-            </a:pPr>
-            <a:r>
-              <a:t>metadata/sources.yaml</a:t>
-            </a:r>
-          </a:p>
-          <a:p>
-            <a:pPr>
-              <a:defRPr sz="2000"/>
-            </a:pPr>
-            <a:r>
-              <a:t>metadata/mappings.yaml</a:t>
-            </a:r>
-          </a:p>
-          <a:p>
-            <a:pPr>
-              <a:defRPr sz="2000"/>
-            </a:pPr>
-            <a:r>
-              <a:t>metadata/routing.yaml</a:t>
-            </a:r>
-          </a:p>
-          <a:p>
-            <a:pPr>
-              <a:defRPr sz="2000"/>
-            </a:pPr>
-            <a:r>
-              <a:t>metadata/validation.yaml</a:t>
-            </a:r>
-          </a:p>
-          <a:p>
-            <a:pPr>
-              <a:defRPr sz="2000"/>
-            </a:pPr>
-            <a:r>
-              <a:t>metadata/streams.yaml</a:t>
-            </a:r>
-          </a:p>
-          <a:p>
-            <a:pPr>
-              <a:defRPr sz="2000"/>
-            </a:pPr>
-            <a:r>
-              <a:t>Principle:</a:t>
-            </a:r>
-          </a:p>
-          <a:p>
-            <a:pPr>
-              <a:defRPr sz="2000"/>
-            </a:pPr>
-            <a:r>
-              <a:t>New source onboarding is primarily metadata and schema updates</a:t>
-            </a:r>
-          </a:p>
-          <a:p>
-            <a:pPr>
-              <a:defRPr sz="2000"/>
-            </a:pPr>
-            <a:r>
-              <a:t>Minimal to no endpoint-handler code changes required</a:t>
+              <a:t>Python 3.12</a:t>
+            </a:r>
+          </a:p>
+          <a:p>
+            <a:pPr>
+              <a:defRPr sz="2000"/>
+            </a:pPr>
+            <a:r>
+              <a:t>FastAPI + Uvicorn</a:t>
+            </a:r>
+          </a:p>
+          <a:p>
+            <a:pPr>
+              <a:defRPr sz="2000"/>
+            </a:pPr>
+            <a:r>
+              <a:t>Pydantic v2 + jsonschema</a:t>
+            </a:r>
+          </a:p>
+          <a:p>
+            <a:pPr>
+              <a:defRPr sz="2000"/>
+            </a:pPr>
+            <a:r>
+              <a:t>SQLAlchemy 2.x + Alembic</a:t>
+            </a:r>
+          </a:p>
+          <a:p>
+            <a:pPr>
+              <a:defRPr sz="2000"/>
+            </a:pPr>
+            <a:r>
+              <a:t>PostgreSQL 16</a:t>
+            </a:r>
+          </a:p>
+          <a:p>
+            <a:pPr>
+              <a:defRPr sz="2000"/>
+            </a:pPr>
+            <a:r>
+              <a:t>LocalStack S3 + Kinesis</a:t>
+            </a:r>
+          </a:p>
+          <a:p>
+            <a:pPr>
+              <a:defRPr sz="2000"/>
+            </a:pPr>
+            <a:r>
+              <a:t>Boto3</a:t>
+            </a:r>
+          </a:p>
+          <a:p>
+            <a:pPr>
+              <a:defRPr sz="2000"/>
+            </a:pPr>
+            <a:r>
+              <a:t>structlog (JSON logging)</a:t>
+            </a:r>
+          </a:p>
+          <a:p>
+            <a:pPr>
+              <a:defRPr sz="2000"/>
+            </a:pPr>
+            <a:r>
+              <a:t>pytest + moto + httpx</a:t>
+            </a:r>
+          </a:p>
+          <a:p>
+            <a:pPr>
+              <a:defRPr sz="2000"/>
+            </a:pPr>
+            <a:r>
+              <a:t>Prometheus + Grafana</a:t>
+            </a:r>
+          </a:p>
+          <a:p>
+            <a:pPr>
+              <a:defRPr sz="2000"/>
+            </a:pPr>
+            <a:r>
+              <a:t>Docker + Docker Compose</a:t>
             </a:r>
           </a:p>
         </p:txBody>
@@ -6208,7 +6486,7 @@
           <a:lstStyle/>
           <a:p>
             <a:r>
-              <a:t>Technology Stack</a:t>
+              <a:t>Repository Structure (High Level)</a:t>
             </a:r>
           </a:p>
         </p:txBody>
@@ -6232,87 +6510,71 @@
               <a:defRPr sz="2000"/>
             </a:pPr>
             <a:r>
-              <a:t>Python 3.12</a:t>
-            </a:r>
-          </a:p>
-          <a:p>
-            <a:pPr>
-              <a:defRPr sz="2000"/>
-            </a:pPr>
-            <a:r>
-              <a:t>FastAPI + Uvicorn</a:t>
-            </a:r>
-          </a:p>
-          <a:p>
-            <a:pPr>
-              <a:defRPr sz="2000"/>
-            </a:pPr>
-            <a:r>
-              <a:t>Pydantic v2 + jsonschema</a:t>
-            </a:r>
-          </a:p>
-          <a:p>
-            <a:pPr>
-              <a:defRPr sz="2000"/>
-            </a:pPr>
-            <a:r>
-              <a:t>SQLAlchemy 2.x + Alembic</a:t>
-            </a:r>
-          </a:p>
-          <a:p>
-            <a:pPr>
-              <a:defRPr sz="2000"/>
-            </a:pPr>
-            <a:r>
-              <a:t>PostgreSQL 16</a:t>
-            </a:r>
-          </a:p>
-          <a:p>
-            <a:pPr>
-              <a:defRPr sz="2000"/>
-            </a:pPr>
-            <a:r>
-              <a:t>LocalStack S3 + Kinesis</a:t>
-            </a:r>
-          </a:p>
-          <a:p>
-            <a:pPr>
-              <a:defRPr sz="2000"/>
-            </a:pPr>
-            <a:r>
-              <a:t>Boto3</a:t>
-            </a:r>
-          </a:p>
-          <a:p>
-            <a:pPr>
-              <a:defRPr sz="2000"/>
-            </a:pPr>
-            <a:r>
-              <a:t>structlog (JSON logging)</a:t>
-            </a:r>
-          </a:p>
-          <a:p>
-            <a:pPr>
-              <a:defRPr sz="2000"/>
-            </a:pPr>
-            <a:r>
-              <a:t>pytest + moto + httpx</a:t>
-            </a:r>
-          </a:p>
-          <a:p>
-            <a:pPr>
-              <a:defRPr sz="2000"/>
-            </a:pPr>
-            <a:r>
-              <a:t>Prometheus + Grafana</a:t>
-            </a:r>
-          </a:p>
-          <a:p>
-            <a:pPr>
-              <a:defRPr sz="2000"/>
-            </a:pPr>
-            <a:r>
-              <a:t>Docker + Docker Compose</a:t>
+              <a:t>config: runtime YAML configuration</a:t>
+            </a:r>
+          </a:p>
+          <a:p>
+            <a:pPr>
+              <a:defRPr sz="2000"/>
+            </a:pPr>
+            <a:r>
+              <a:t>metadata: source/routing/validation/stream definitions</a:t>
+            </a:r>
+          </a:p>
+          <a:p>
+            <a:pPr>
+              <a:defRPr sz="2000"/>
+            </a:pPr>
+            <a:r>
+              <a:t>schemas: per-source JSON schemas</a:t>
+            </a:r>
+          </a:p>
+          <a:p>
+            <a:pPr>
+              <a:defRPr sz="2000"/>
+            </a:pPr>
+            <a:r>
+              <a:t>sample-data: test payloads</a:t>
+            </a:r>
+          </a:p>
+          <a:p>
+            <a:pPr>
+              <a:defRPr sz="2000"/>
+            </a:pPr>
+            <a:r>
+              <a:t>common: shared components (models, validation, storage, aws, repository)</a:t>
+            </a:r>
+          </a:p>
+          <a:p>
+            <a:pPr>
+              <a:defRPr sz="2000"/>
+            </a:pPr>
+            <a:r>
+              <a:t>ingestion-service: API service implementation</a:t>
+            </a:r>
+          </a:p>
+          <a:p>
+            <a:pPr>
+              <a:defRPr sz="2000"/>
+            </a:pPr>
+            <a:r>
+              <a:t>infrastructure/postgres/init.sql: DB bootstrap</a:t>
+            </a:r>
+          </a:p>
+          <a:p>
+            <a:pPr>
+              <a:defRPr sz="2000"/>
+            </a:pPr>
+            <a:r>
+              <a:t>infrastructure/localstack/init-aws.sh: S3/Kinesis bootstrap</a:t>
+            </a:r>
+          </a:p>
+          <a:p>
+            <a:pPr>
+              <a:defRPr sz="2000"/>
+            </a:pPr>
+            <a:r>
+              <a:t>tests: offline-capable pytest suite</a:t>
             </a:r>
           </a:p>
         </p:txBody>

</xml_diff>